<commit_message>
LinkedIn: revise task allocation, repair cross-table inconsistencies, refresh guides
</commit_message>
<xml_diff>
--- a/DOTE6751_LinkedIn/slides/LinkedIn.pptx
+++ b/DOTE6751_LinkedIn/slides/LinkedIn.pptx
@@ -14540,7 +14540,7 @@
                 </a:solidFill>
                 <a:latin typeface="Segoe UI"/>
               </a:rPr>
-              <a:t>Business queries Q07–Q13 and the CSV capture harness</a:t>
+              <a:t>Query layer Q01–Q13 (lookups and business analysis) and the CSV capture harness</a:t>
             </a:r>
           </a:p>
         </p:txBody>
@@ -14630,7 +14630,7 @@
                 </a:solidFill>
                 <a:latin typeface="Segoe UI"/>
               </a:rPr>
-              <a:t>11</a:t>
+              <a:t>12</a:t>
             </a:r>
           </a:p>
         </p:txBody>
@@ -15245,7 +15245,7 @@
                 </a:solidFill>
                 <a:latin typeface="Segoe UI"/>
               </a:rPr>
-              <a:t>Acceptance: 12 checks, fault-injection suite, consistency audit</a:t>
+              <a:t>Acceptance: 12 checks and the fault-injection suite</a:t>
             </a:r>
           </a:p>
         </p:txBody>
@@ -15335,7 +15335,7 @@
                 </a:solidFill>
                 <a:latin typeface="Segoe UI"/>
               </a:rPr>
-              <a:t>9</a:t>
+              <a:t>10</a:t>
             </a:r>
           </a:p>
         </p:txBody>
@@ -15380,7 +15380,7 @@
                 </a:solidFill>
                 <a:latin typeface="Segoe UI"/>
               </a:rPr>
-              <a:t>Total 81 person-hours · average 11.6 h · no task below difficulty 4 · every member reviewed at least one artefact they did not author.</a:t>
+              <a:t>Total 83 person-hours · average 11.9 h · no task below difficulty 4 · every member reviewed at least one artefact they did not author.</a:t>
             </a:r>
           </a:p>
         </p:txBody>
@@ -15457,7 +15457,7 @@
                 </a:solidFill>
                 <a:latin typeface="Segoe UI"/>
               </a:rPr>
-              <a:t>81 h</a:t>
+              <a:t>83 h</a:t>
             </a:r>
           </a:p>
         </p:txBody>

</xml_diff>